<commit_message>
Add proposal PPTX: Umina Legal (June 30, 2026) — FCOO + FCFO package, corrected urgency score 7 and Google review counts
Co-Authored-By: Claude Sonnet 4.6 <noreply@anthropic.com>
</commit_message>
<xml_diff>
--- a/umina-legal/UminaLegal_June30_2026_Proposal.pptx
+++ b/umina-legal/UminaLegal_June30_2026_Proposal.pptx
@@ -3319,7 +3319,7 @@
                 </a:solidFill>
                 <a:latin typeface="Calibri"/>
               </a:rPr>
-              <a:t>6</a:t>
+              <a:t>7</a:t>
             </a:r>
           </a:p>
         </p:txBody>
@@ -3730,7 +3730,7 @@
                 </a:solidFill>
                 <a:latin typeface="Calibri"/>
               </a:rPr>
-              <a:t>Ryan handles all intake</a:t>
+              <a:t>Attorney handles all intake</a:t>
             </a:r>
           </a:p>
         </p:txBody>
@@ -3919,7 +3919,7 @@
                 </a:solidFill>
                 <a:latin typeface="Calibri"/>
               </a:rPr>
-              <a:t>No management layer</a:t>
+              <a:t>No delegation layer</a:t>
             </a:r>
           </a:p>
         </p:txBody>
@@ -4108,7 +4108,7 @@
                 </a:solidFill>
                 <a:latin typeface="Calibri"/>
               </a:rPr>
-              <a:t>No financial visibility</a:t>
+              <a:t>No P&amp;L visibility</a:t>
             </a:r>
           </a:p>
         </p:txBody>
@@ -4297,7 +4297,7 @@
                 </a:solidFill>
                 <a:latin typeface="Calibri"/>
               </a:rPr>
-              <a:t>Intake bottleneck — Ryan answers every call; growth multiplies his load</a:t>
+              <a:t>Intake handled personally — structural burnout risk before $2M</a:t>
             </a:r>
           </a:p>
         </p:txBody>
@@ -4453,7 +4453,7 @@
                 </a:solidFill>
                 <a:latin typeface="Calibri"/>
               </a:rPr>
-              <a:t>No CRM, weak bookkeeping — $100K/mo with zero financial visibility</a:t>
+              <a:t>$100K/month with no bookkeeping, CRM, or P&amp;L visibility</a:t>
             </a:r>
           </a:p>
         </p:txBody>
@@ -4609,7 +4609,7 @@
                 </a:solidFill>
                 <a:latin typeface="Calibri"/>
               </a:rPr>
-              <a:t>Competitors have 20+ Avvo reviews; Umina Legal not in main rankings</a:t>
+              <a:t>Slavey &amp; Shumaker: 101 reviews vs. Umina's 0 — gap grows monthly</a:t>
             </a:r>
           </a:p>
         </p:txBody>
@@ -4765,7 +4765,7 @@
                 </a:solidFill>
                 <a:latin typeface="Calibri"/>
               </a:rPr>
-              <a:t>$100K/mo from one Google Ads campaign — strong paid foundation to build on</a:t>
+              <a:t>Self-managed Google Ads already drives $100K/mo — proven demand</a:t>
             </a:r>
           </a:p>
         </p:txBody>
@@ -5110,7 +5110,7 @@
                 </a:solidFill>
                 <a:latin typeface="Calibri"/>
               </a:rPr>
-              <a:t>21 Avvo reviews</a:t>
+              <a:t>101 reviews</a:t>
             </a:r>
           </a:p>
         </p:txBody>
@@ -5143,7 +5143,7 @@
                 </a:solidFill>
                 <a:latin typeface="Calibri"/>
               </a:rPr>
-              <a:t>10.0 rating · top Morgantown ranking</a:t>
+              <a:t>4.8 stars · anchors local 3-pack</a:t>
             </a:r>
           </a:p>
         </p:txBody>
@@ -5254,7 +5254,7 @@
                 </a:solidFill>
                 <a:latin typeface="Calibri"/>
               </a:rPr>
-              <a:t>20 Avvo reviews</a:t>
+              <a:t>~40 reviews</a:t>
             </a:r>
           </a:p>
         </p:txBody>
@@ -5287,7 +5287,7 @@
                 </a:solidFill>
                 <a:latin typeface="Calibri"/>
               </a:rPr>
-              <a:t>9.1 rating · consistent directory presence</a:t>
+              <a:t>4.7 stars · AV Preeminent rated</a:t>
             </a:r>
           </a:p>
         </p:txBody>
@@ -5365,7 +5365,7 @@
                 </a:solidFill>
                 <a:latin typeface="Calibri"/>
               </a:rPr>
-              <a:t>Candace Ogle Law</a:t>
+              <a:t>Mountaineer Criminal Law</a:t>
             </a:r>
           </a:p>
         </p:txBody>
@@ -5398,7 +5398,7 @@
                 </a:solidFill>
                 <a:latin typeface="Calibri"/>
               </a:rPr>
-              <a:t>8 Avvo reviews</a:t>
+              <a:t>9 reviews</a:t>
             </a:r>
           </a:p>
         </p:txBody>
@@ -5431,7 +5431,7 @@
                 </a:solidFill>
                 <a:latin typeface="Calibri"/>
               </a:rPr>
-              <a:t>7.6 rating · Yellow Pages + Avvo listed</a:t>
+              <a:t>4.1 stars · crim-def domain</a:t>
             </a:r>
           </a:p>
         </p:txBody>
@@ -5587,7 +5587,7 @@
                 </a:solidFill>
                 <a:latin typeface="Calibri"/>
               </a:rPr>
-              <a:t>Not ranked</a:t>
+              <a:t>0 visible reviews</a:t>
             </a:r>
           </a:p>
         </p:txBody>
@@ -5620,7 +5620,7 @@
                 </a:solidFill>
                 <a:latin typeface="Calibri"/>
               </a:rPr>
-              <a:t>← Not in Avvo rankings</a:t>
+              <a:t>← You are here</a:t>
             </a:r>
           </a:p>
         </p:txBody>
@@ -6040,7 +6040,7 @@
                 </a:solidFill>
                 <a:latin typeface="Calibri"/>
               </a:rPr>
-              <a:t>The SMB Growth Model builds four pillars at once: Lead Generation, Intake, Team, and Profit. When all four work together, Ryan can finally step back from the day-to-day — and the firm generates $2M without generating burnout.</a:t>
+              <a:t>SMB Team builds four pillars together: Lead Generation, Intake, Team, and Profit. Most firms work one at a time — and stall. When all four are working, Ryan can scale past $2M without adding a single hour to his week.</a:t>
             </a:r>
           </a:p>
         </p:txBody>
@@ -6118,7 +6118,7 @@
                 </a:solidFill>
                 <a:latin typeface="Calibri"/>
               </a:rPr>
-              <a:t>$1.2M → $2M annual revenue</a:t>
+              <a:t>$1.2M → $2M revenue</a:t>
             </a:r>
           </a:p>
         </p:txBody>
@@ -6151,7 +6151,7 @@
                 </a:solidFill>
                 <a:latin typeface="Calibri"/>
               </a:rPr>
-              <a:t>Step back. Work 30 hrs. Firm runs itself.</a:t>
+              <a:t>Scale to $2M — work 30 hours a week</a:t>
             </a:r>
           </a:p>
         </p:txBody>
@@ -6262,7 +6262,7 @@
                 </a:solidFill>
                 <a:latin typeface="Calibri"/>
               </a:rPr>
-              <a:t>Build the</a:t>
+              <a:t>Fix Intake &amp;</a:t>
             </a:r>
           </a:p>
         </p:txBody>
@@ -6295,7 +6295,7 @@
                 </a:solidFill>
                 <a:latin typeface="Calibri"/>
               </a:rPr>
-              <a:t>Marketing Engine</a:t>
+              <a:t>Stop Losing Cases</a:t>
             </a:r>
           </a:p>
         </p:txBody>
@@ -6418,7 +6418,7 @@
                 </a:solidFill>
                 <a:latin typeface="Calibri"/>
               </a:rPr>
-              <a:t>Expand Google Ads: professional managed campaigns</a:t>
+              <a:t>Hire a trained intake coordinator — free Ryan</a:t>
             </a:r>
           </a:p>
         </p:txBody>
@@ -6541,7 +6541,7 @@
                 </a:solidFill>
                 <a:latin typeface="Calibri"/>
               </a:rPr>
-              <a:t>Launch satellite markets: Parkersburg, Charleston</a:t>
+              <a:t>Cover every call — court days, nights, weekends</a:t>
             </a:r>
           </a:p>
         </p:txBody>
@@ -6664,7 +6664,7 @@
                 </a:solidFill>
                 <a:latin typeface="Calibri"/>
               </a:rPr>
-              <a:t>Get Google Screened — own the top LSA placement</a:t>
+              <a:t>Rebuild Practice Panther — clean lead tracking</a:t>
             </a:r>
           </a:p>
         </p:txBody>
@@ -6787,7 +6787,7 @@
                 </a:solidFill>
                 <a:latin typeface="Calibri"/>
               </a:rPr>
-              <a:t>Fix mobile PageSpeed to convert paid traffic better</a:t>
+              <a:t>Build intake script tied to Ryan's quality bar</a:t>
             </a:r>
           </a:p>
         </p:txBody>
@@ -6910,7 +6910,7 @@
                 </a:solidFill>
                 <a:latin typeface="Calibri"/>
               </a:rPr>
-              <a:t>Turn Google into a pipeline that runs without you</a:t>
+              <a:t>Know close rate — stop guessing on ad ROI</a:t>
             </a:r>
           </a:p>
         </p:txBody>
@@ -7021,7 +7021,7 @@
                 </a:solidFill>
                 <a:latin typeface="Calibri"/>
               </a:rPr>
-              <a:t>Fix Intake &amp;</a:t>
+              <a:t>Build the</a:t>
             </a:r>
           </a:p>
         </p:txBody>
@@ -7054,7 +7054,7 @@
                 </a:solidFill>
                 <a:latin typeface="Calibri"/>
               </a:rPr>
-              <a:t>Stop Losing Cases</a:t>
+              <a:t>Operations Layer</a:t>
             </a:r>
           </a:p>
         </p:txBody>
@@ -7177,7 +7177,7 @@
                 </a:solidFill>
                 <a:latin typeface="Calibri"/>
               </a:rPr>
-              <a:t>Hire + train a dedicated intake coordinator</a:t>
+              <a:t>Delegate ops — Ryan focuses on cases, not admin</a:t>
             </a:r>
           </a:p>
         </p:txBody>
@@ -7300,7 +7300,7 @@
                 </a:solidFill>
                 <a:latin typeface="Calibri"/>
               </a:rPr>
-              <a:t>Rebuild Practice Panther with clean CRM tracking</a:t>
+              <a:t>Define every team role with clear accountability</a:t>
             </a:r>
           </a:p>
         </p:txBody>
@@ -7423,7 +7423,7 @@
                 </a:solidFill>
                 <a:latin typeface="Calibri"/>
               </a:rPr>
-              <a:t>Define intake script to Ryan's exact standards</a:t>
+              <a:t>Weekly ops rhythm Ryan can step back from</a:t>
             </a:r>
           </a:p>
         </p:txBody>
@@ -7546,7 +7546,7 @@
                 </a:solidFill>
                 <a:latin typeface="Calibri"/>
               </a:rPr>
-              <a:t>Add after-hours coverage — no lead hits voicemail</a:t>
+              <a:t>Build process docs the next hire steps into</a:t>
             </a:r>
           </a:p>
         </p:txBody>
@@ -7669,7 +7669,7 @@
                 </a:solidFill>
                 <a:latin typeface="Calibri"/>
               </a:rPr>
-              <a:t>Convert more leads from the $3K/mo already spent</a:t>
+              <a:t>FCOO builds the firm that runs without you</a:t>
             </a:r>
           </a:p>
         </p:txBody>
@@ -7780,7 +7780,7 @@
                 </a:solidFill>
                 <a:latin typeface="Calibri"/>
               </a:rPr>
-              <a:t>Install Team &amp;</a:t>
+              <a:t>Install Financial</a:t>
             </a:r>
           </a:p>
         </p:txBody>
@@ -7813,7 +7813,7 @@
                 </a:solidFill>
                 <a:latin typeface="Calibri"/>
               </a:rPr>
-              <a:t>Profit Systems</a:t>
+              <a:t>Clarity Systems</a:t>
             </a:r>
           </a:p>
         </p:txBody>
@@ -7936,7 +7936,7 @@
                 </a:solidFill>
                 <a:latin typeface="Calibri"/>
               </a:rPr>
-              <a:t>Engage bookkeeping for monthly P&amp;L visibility</a:t>
+              <a:t>Bookkeeping from day 1 — no guessing margins</a:t>
             </a:r>
           </a:p>
         </p:txBody>
@@ -8059,7 +8059,7 @@
                 </a:solidFill>
                 <a:latin typeface="Calibri"/>
               </a:rPr>
-              <a:t>Build role clarity + accountability for the team</a:t>
+              <a:t>Monthly P&amp;L — know what the firm actually keeps</a:t>
             </a:r>
           </a:p>
         </p:txBody>
@@ -8182,7 +8182,7 @@
                 </a:solidFill>
                 <a:latin typeface="Calibri"/>
               </a:rPr>
-              <a:t>Track cost-per-acquisition from Google Ads spend</a:t>
+              <a:t>Track cost-per-acquisition on every ad dollar</a:t>
             </a:r>
           </a:p>
         </p:txBody>
@@ -8305,7 +8305,7 @@
                 </a:solidFill>
                 <a:latin typeface="Calibri"/>
               </a:rPr>
-              <a:t>Create the team structure that lets Ryan step back</a:t>
+              <a:t>Financial model for the path to $2M — data-based</a:t>
             </a:r>
           </a:p>
         </p:txBody>
@@ -8428,7 +8428,7 @@
                 </a:solidFill>
                 <a:latin typeface="Calibri"/>
               </a:rPr>
-              <a:t>Plan the 30-hour week before $2M — not after it</a:t>
+              <a:t>FCFO turns profit from guess to engineered plan</a:t>
             </a:r>
           </a:p>
         </p:txBody>
@@ -8757,7 +8757,7 @@
             <a:avLst/>
           </a:prstGeom>
           <a:solidFill>
-            <a:srgbClr val="1D4ED8"/>
+            <a:srgbClr val="0F766E"/>
           </a:solidFill>
           <a:ln>
             <a:solidFill>
@@ -8811,11 +8811,11 @@
             <a:r>
               <a:rPr sz="800" b="1" i="0">
                 <a:solidFill>
-                  <a:srgbClr val="1D4ED8"/>
-                </a:solidFill>
-                <a:latin typeface="Calibri"/>
-              </a:rPr>
-              <a:t>FULL SERVICE MARKETING — GROWTH</a:t>
+                  <a:srgbClr val="0F766E"/>
+                </a:solidFill>
+                <a:latin typeface="Calibri"/>
+              </a:rPr>
+              <a:t>FRACTIONAL COO ADVISOR</a:t>
             </a:r>
           </a:p>
         </p:txBody>
@@ -8848,7 +8848,7 @@
                 </a:solidFill>
                 <a:latin typeface="Calibri"/>
               </a:rPr>
-              <a:t>$6,397</a:t>
+              <a:t>$1,297</a:t>
             </a:r>
           </a:p>
         </p:txBody>
@@ -8914,7 +8914,7 @@
                 </a:solidFill>
                 <a:latin typeface="Calibri"/>
               </a:rPr>
-              <a:t>$6,997/mo</a:t>
+              <a:t>$1,797/mo</a:t>
             </a:r>
           </a:p>
         </p:txBody>
@@ -8992,7 +8992,7 @@
                 </a:solidFill>
                 <a:latin typeface="Calibri"/>
               </a:rPr>
-              <a:t>Google Ads · LSA · Website · Local SEO · Meta retargeting</a:t>
+              <a:t>Ops advisory · Intake framework · Team structure · Coaching included</a:t>
             </a:r>
           </a:p>
         </p:txBody>
@@ -9115,7 +9115,7 @@
                 </a:solidFill>
                 <a:latin typeface="Calibri"/>
               </a:rPr>
-              <a:t>ELITE COACH PLUS</a:t>
+              <a:t>FRACTIONAL CFO ADVISOR</a:t>
             </a:r>
           </a:p>
         </p:txBody>
@@ -9148,7 +9148,7 @@
                 </a:solidFill>
                 <a:latin typeface="Calibri"/>
               </a:rPr>
-              <a:t>$3,200</a:t>
+              <a:t>$1,297</a:t>
             </a:r>
           </a:p>
         </p:txBody>
@@ -9214,7 +9214,7 @@
                 </a:solidFill>
                 <a:latin typeface="Calibri"/>
               </a:rPr>
-              <a:t>$3,497/mo</a:t>
+              <a:t>$1,797/mo</a:t>
             </a:r>
           </a:p>
         </p:txBody>
@@ -9292,7 +9292,7 @@
                 </a:solidFill>
                 <a:latin typeface="Calibri"/>
               </a:rPr>
-              <a:t>Weekly coaching · Intake framework · Masterminds · Workshops</a:t>
+              <a:t>Financial advisory · Bookkeeping oversight · P&amp;L · Coaching included</a:t>
             </a:r>
           </a:p>
         </p:txBody>
@@ -9403,7 +9403,7 @@
                 </a:solidFill>
                 <a:latin typeface="Calibri"/>
               </a:rPr>
-              <a:t>$9,597 / mo</a:t>
+              <a:t>$2,594 / mo</a:t>
             </a:r>
           </a:p>
         </p:txBody>
@@ -9436,7 +9436,7 @@
                 </a:solidFill>
                 <a:latin typeface="Calibri"/>
               </a:rPr>
-              <a:t>Save $897/mo by bundling</a:t>
+              <a:t>Save $1,000/mo by bundling</a:t>
             </a:r>
           </a:p>
         </p:txBody>
@@ -9514,7 +9514,7 @@
                 </a:solidFill>
                 <a:latin typeface="Calibri"/>
               </a:rPr>
-              <a:t>+ Recommended ad spend: $7,500–$25,000/mo paid directly to Google/Meta</a:t>
+              <a:t>+ Advisory: $7,500–$25,000/mo self-managed ad spend paid directly to Google</a:t>
             </a:r>
           </a:p>
         </p:txBody>
@@ -9658,7 +9658,7 @@
                 </a:solidFill>
                 <a:latin typeface="Calibri"/>
               </a:rPr>
-              <a:t>~$7,000 (est.)</a:t>
+              <a:t>~$7,000 (practice area default)</a:t>
             </a:r>
           </a:p>
         </p:txBody>
@@ -9769,7 +9769,7 @@
                 </a:solidFill>
                 <a:latin typeface="Calibri"/>
               </a:rPr>
-              <a:t>~$17,500 revenue · ~2× ROAS</a:t>
+              <a:t>~$17,500 revenue · ~2x ROAS</a:t>
             </a:r>
           </a:p>
         </p:txBody>
@@ -9835,7 +9835,7 @@
                 </a:solidFill>
                 <a:latin typeface="Calibri"/>
               </a:rPr>
-              <a:t>~$63,000 revenue · ~2.5× ROAS</a:t>
+              <a:t>~$63,000 revenue · ~2.5x ROAS</a:t>
             </a:r>
           </a:p>
         </p:txBody>
@@ -9979,7 +9979,7 @@
                 </a:solidFill>
                 <a:latin typeface="Calibri"/>
               </a:rPr>
-              <a:t>Google Ads expansion + satellite markets scoped</a:t>
+              <a:t>FCOO + FCFO engagements begin — ops audit starts</a:t>
             </a:r>
           </a:p>
         </p:txBody>
@@ -10090,7 +10090,7 @@
                 </a:solidFill>
                 <a:latin typeface="Calibri"/>
               </a:rPr>
-              <a:t>Satellite market campaigns live; website work begins</a:t>
+              <a:t>Intake coordinator job description delivered</a:t>
             </a:r>
           </a:p>
         </p:txBody>
@@ -10201,7 +10201,7 @@
                 </a:solidFill>
                 <a:latin typeface="Calibri"/>
               </a:rPr>
-              <a:t>Google Screened verification process initiated</a:t>
+              <a:t>Bookkeeping vendor engaged — P&amp;L baseline set</a:t>
             </a:r>
           </a:p>
         </p:txBody>
@@ -10312,7 +10312,7 @@
                 </a:solidFill>
                 <a:latin typeface="Calibri"/>
               </a:rPr>
-              <a:t>Intake coordinator job description + hiring begins</a:t>
+              <a:t>Intake coordinator hiring process begins</a:t>
             </a:r>
           </a:p>
         </p:txBody>
@@ -10423,7 +10423,7 @@
                 </a:solidFill>
                 <a:latin typeface="Calibri"/>
               </a:rPr>
-              <a:t>P&amp;L baseline set; first monthly financial review</a:t>
+              <a:t>Coordinator trained; first monthly P&amp;L delivered</a:t>
             </a:r>
           </a:p>
         </p:txBody>
@@ -10501,7 +10501,7 @@
                 </a:solidFill>
                 <a:latin typeface="Calibri"/>
               </a:rPr>
-              <a:t>"I want to shift from operator to owner — and know my firm is running, even when I'm not in it."</a:t>
+              <a:t>“Scale to $2M — work 30 hours a week — without the burnout that came before. That is the firm we are building.”</a:t>
             </a:r>
           </a:p>
         </p:txBody>

</xml_diff>